<commit_message>
Agregar mapa de ubicación referencial a las fichas Chávez, Quispe Ali y Quispe de Quispe
Co-Authored-By: Claude Sonnet 5.5 <noreply@anthropic.com>
Claude-Session: https://claude.ai/code/session_01VhqT6yn6eqZyshscX6tQHD
</commit_message>
<xml_diff>
--- a/Informe_5_Casos_Patrimoniales_Viacha_2026_v2.pptx
+++ b/Informe_5_Casos_Patrimoniales_Viacha_2026_v2.pptx
@@ -13419,16 +13419,39 @@
           </a:ln>
         </p:spPr>
       </p:sp>
-      <p:sp>
-        <p:nvSpPr>
-          <p:cNvPr id="3" name="Etiqueta"/>
+      <p:pic>
+        <p:nvPicPr>
+          <p:cNvPr id="3" name="Image 0" descr="Mapa referencial de la zona Mamani y la ciudad de Viacha">    </p:cNvPr>
+          <p:cNvPicPr>
+            <a:picLocks noChangeAspect="1"/>
+          </p:cNvPicPr>
+          <p:nvPr/>
+        </p:nvPicPr>
+        <p:blipFill>
+          <a:blip r:embed="rId1"/>
+          <a:srcRect l="0" r="0" t="0" b="0"/>
+          <a:stretch/>
+        </p:blipFill>
+        <p:spPr>
+          <a:xfrm>
+            <a:off x="0" y="0"/>
+            <a:ext cx="4023360" cy="2651760"/>
+          </a:xfrm>
+          <a:prstGeom prst="rect">
+            <a:avLst/>
+          </a:prstGeom>
+        </p:spPr>
+      </p:pic>
+      <p:sp>
+        <p:nvSpPr>
+          <p:cNvPr id="4" name="Etiqueta"/>
           <p:cNvSpPr/>
           <p:nvPr/>
         </p:nvSpPr>
         <p:spPr>
           <a:xfrm>
-            <a:off x="457200" y="457200"/>
-            <a:ext cx="3108960" cy="822960"/>
+            <a:off x="274320" y="274320"/>
+            <a:ext cx="2286000" cy="731520"/>
           </a:xfrm>
           <a:prstGeom prst="rect">
             <a:avLst/>
@@ -13446,14 +13469,14 @@
       </p:sp>
       <p:sp>
         <p:nvSpPr>
-          <p:cNvPr id="4" name="Etiqueta barra"/>
+          <p:cNvPr id="5" name="Etiqueta barra"/>
           <p:cNvSpPr/>
           <p:nvPr/>
         </p:nvSpPr>
         <p:spPr>
           <a:xfrm>
-            <a:off x="457200" y="457200"/>
-            <a:ext cx="64008" cy="822960"/>
+            <a:off x="274320" y="274320"/>
+            <a:ext cx="64008" cy="731520"/>
           </a:xfrm>
           <a:prstGeom prst="rect">
             <a:avLst/>
@@ -13471,14 +13494,14 @@
       </p:sp>
       <p:sp>
         <p:nvSpPr>
-          <p:cNvPr id="5" name="Text 3"/>
-          <p:cNvSpPr txBox="1"/>
-          <p:nvPr/>
-        </p:nvSpPr>
-        <p:spPr>
-          <a:xfrm>
-            <a:off x="731520" y="457200"/>
-            <a:ext cx="2743200" cy="822960"/>
+          <p:cNvPr id="6" name="Text 3"/>
+          <p:cNvSpPr txBox="1"/>
+          <p:nvPr/>
+        </p:nvSpPr>
+        <p:spPr>
+          <a:xfrm>
+            <a:off x="548640" y="274320"/>
+            <a:ext cx="1920240" cy="731520"/>
           </a:xfrm>
           <a:prstGeom prst="rect">
             <a:avLst/>
@@ -13494,7 +13517,7 @@
               <a:buNone/>
             </a:pPr>
             <a:r>
-              <a:rPr lang="en-US" sz="1300" dirty="0">
+              <a:rPr lang="en-US" sz="1200" dirty="0">
                 <a:solidFill>
                   <a:srgbClr val="FFFFFF"/>
                 </a:solidFill>
@@ -13511,7 +13534,7 @@
               <a:buNone/>
             </a:pPr>
             <a:r>
-              <a:rPr lang="en-US" sz="1800" b="1" dirty="0">
+              <a:rPr lang="en-US" sz="1600" b="1" dirty="0">
                 <a:solidFill>
                   <a:srgbClr val="FFFFFF"/>
                 </a:solidFill>
@@ -13527,13 +13550,77 @@
       </p:sp>
       <p:sp>
         <p:nvSpPr>
-          <p:cNvPr id="6" name="Text 4"/>
-          <p:cNvSpPr txBox="1"/>
-          <p:nvPr/>
-        </p:nvSpPr>
-        <p:spPr>
-          <a:xfrm>
-            <a:off x="457200" y="1737360"/>
+          <p:cNvPr id="7" name="Shape 4"/>
+          <p:cNvSpPr/>
+          <p:nvPr/>
+        </p:nvSpPr>
+        <p:spPr>
+          <a:xfrm>
+            <a:off x="0" y="2286000"/>
+            <a:ext cx="4023360" cy="365760"/>
+          </a:xfrm>
+          <a:prstGeom prst="rect">
+            <a:avLst/>
+          </a:prstGeom>
+          <a:solidFill>
+            <a:srgbClr val="1B2126"/>
+          </a:solidFill>
+          <a:ln w="12700">
+            <a:solidFill>
+              <a:srgbClr val="1B2126"/>
+            </a:solidFill>
+            <a:prstDash val="solid"/>
+          </a:ln>
+        </p:spPr>
+      </p:sp>
+      <p:sp>
+        <p:nvSpPr>
+          <p:cNvPr id="8" name="Text 5"/>
+          <p:cNvSpPr txBox="1"/>
+          <p:nvPr/>
+        </p:nvSpPr>
+        <p:spPr>
+          <a:xfrm>
+            <a:off x="274320" y="2286000"/>
+            <a:ext cx="3657600" cy="365760"/>
+          </a:xfrm>
+          <a:prstGeom prst="rect">
+            <a:avLst/>
+          </a:prstGeom>
+          <a:noFill/>
+          <a:ln/>
+        </p:spPr>
+        <p:txBody>
+          <a:bodyPr wrap="square" lIns="0" tIns="0" rIns="0" bIns="0" rtlCol="0" anchor="ctr"/>
+          <a:lstStyle/>
+          <a:p>
+            <a:pPr indent="0" marL="0">
+              <a:buNone/>
+            </a:pPr>
+            <a:r>
+              <a:rPr lang="en-US" sz="900" b="1" spc="50" kern="0" dirty="0">
+                <a:solidFill>
+                  <a:srgbClr val="FFFFFF"/>
+                </a:solidFill>
+                <a:latin typeface="Arial" pitchFamily="34" charset="0"/>
+                <a:ea typeface="Arial" pitchFamily="34" charset="-122"/>
+                <a:cs typeface="Arial" pitchFamily="34" charset="-120"/>
+              </a:rPr>
+              <a:t>UBICACIÓN REFERENCIAL · NO DELIMITA EL PREDIO</a:t>
+            </a:r>
+            <a:endParaRPr lang="en-US" sz="900" dirty="0"/>
+          </a:p>
+        </p:txBody>
+      </p:sp>
+      <p:sp>
+        <p:nvSpPr>
+          <p:cNvPr id="9" name="Text 6"/>
+          <p:cNvSpPr txBox="1"/>
+          <p:nvPr/>
+        </p:nvSpPr>
+        <p:spPr>
+          <a:xfrm>
+            <a:off x="457200" y="2834640"/>
             <a:ext cx="3200400" cy="274320"/>
           </a:xfrm>
           <a:prstGeom prst="rect">
@@ -13566,14 +13653,14 @@
       </p:sp>
       <p:sp>
         <p:nvSpPr>
-          <p:cNvPr id="7" name="Text 5"/>
-          <p:cNvSpPr txBox="1"/>
-          <p:nvPr/>
-        </p:nvSpPr>
-        <p:spPr>
-          <a:xfrm>
-            <a:off x="457200" y="2011680"/>
-            <a:ext cx="3291840" cy="868680"/>
+          <p:cNvPr id="10" name="Text 7"/>
+          <p:cNvSpPr txBox="1"/>
+          <p:nvPr/>
+        </p:nvSpPr>
+        <p:spPr>
+          <a:xfrm>
+            <a:off x="457200" y="3108960"/>
+            <a:ext cx="3383280" cy="685800"/>
           </a:xfrm>
           <a:prstGeom prst="rect">
             <a:avLst/>
@@ -13589,7 +13676,7 @@
               <a:buNone/>
             </a:pPr>
             <a:r>
-              <a:rPr lang="en-US" sz="5400" b="1" dirty="0">
+              <a:rPr lang="en-US" sz="4400" b="1" dirty="0">
                 <a:solidFill>
                   <a:srgbClr val="FFFFFF"/>
                 </a:solidFill>
@@ -13599,20 +13686,34 @@
               </a:rPr>
               <a:t>9,3250</a:t>
             </a:r>
-            <a:endParaRPr lang="en-US" sz="5400" dirty="0"/>
-          </a:p>
-        </p:txBody>
-      </p:sp>
-      <p:sp>
-        <p:nvSpPr>
-          <p:cNvPr id="8" name="Text 6"/>
-          <p:cNvSpPr txBox="1"/>
-          <p:nvPr/>
-        </p:nvSpPr>
-        <p:spPr>
-          <a:xfrm>
-            <a:off x="457200" y="2880360"/>
-            <a:ext cx="3200400" cy="274320"/>
+            <a:pPr indent="0" marL="0">
+              <a:buNone/>
+            </a:pPr>
+            <a:r>
+              <a:rPr lang="en-US" sz="1600" dirty="0">
+                <a:solidFill>
+                  <a:srgbClr val="C9CED3"/>
+                </a:solidFill>
+                <a:latin typeface="Arial" pitchFamily="34" charset="0"/>
+                <a:ea typeface="Arial" pitchFamily="34" charset="-122"/>
+                <a:cs typeface="Arial" pitchFamily="34" charset="-120"/>
+              </a:rPr>
+              <a:t>  ha</a:t>
+            </a:r>
+            <a:endParaRPr lang="en-US" sz="1400" dirty="0"/>
+          </a:p>
+        </p:txBody>
+      </p:sp>
+      <p:sp>
+        <p:nvSpPr>
+          <p:cNvPr id="11" name="Text 8"/>
+          <p:cNvSpPr txBox="1"/>
+          <p:nvPr/>
+        </p:nvSpPr>
+        <p:spPr>
+          <a:xfrm>
+            <a:off x="457200" y="3886200"/>
+            <a:ext cx="3200400" cy="228600"/>
           </a:xfrm>
           <a:prstGeom prst="rect">
             <a:avLst/>
@@ -13628,7 +13729,7 @@
               <a:buNone/>
             </a:pPr>
             <a:r>
-              <a:rPr lang="en-US" sz="1400" dirty="0">
+              <a:rPr lang="en-US" sz="1200" dirty="0">
                 <a:solidFill>
                   <a:srgbClr val="C9CED3"/>
                 </a:solidFill>
@@ -13636,7 +13737,124 @@
                 <a:ea typeface="Arial" pitchFamily="34" charset="-122"/>
                 <a:cs typeface="Arial" pitchFamily="34" charset="-120"/>
               </a:rPr>
-              <a:t>hectáreas</a:t>
+              <a:t>Matrícula</a:t>
+            </a:r>
+            <a:endParaRPr lang="en-US" sz="1200" dirty="0"/>
+          </a:p>
+        </p:txBody>
+      </p:sp>
+      <p:sp>
+        <p:nvSpPr>
+          <p:cNvPr id="12" name="Text 9"/>
+          <p:cNvSpPr txBox="1"/>
+          <p:nvPr/>
+        </p:nvSpPr>
+        <p:spPr>
+          <a:xfrm>
+            <a:off x="457200" y="4114800"/>
+            <a:ext cx="3291840" cy="320040"/>
+          </a:xfrm>
+          <a:prstGeom prst="rect">
+            <a:avLst/>
+          </a:prstGeom>
+          <a:noFill/>
+          <a:ln/>
+        </p:spPr>
+        <p:txBody>
+          <a:bodyPr wrap="square" lIns="0" tIns="0" rIns="0" bIns="0" rtlCol="0" anchor="t"/>
+          <a:lstStyle/>
+          <a:p>
+            <a:pPr indent="0" marL="0">
+              <a:buNone/>
+            </a:pPr>
+            <a:r>
+              <a:rPr lang="en-US" sz="1700" b="1" dirty="0">
+                <a:solidFill>
+                  <a:srgbClr val="FFFFFF"/>
+                </a:solidFill>
+                <a:latin typeface="Arial" pitchFamily="34" charset="0"/>
+                <a:ea typeface="Arial" pitchFamily="34" charset="-122"/>
+                <a:cs typeface="Arial" pitchFamily="34" charset="-120"/>
+              </a:rPr>
+              <a:t>2.08.1.01.0019611</a:t>
+            </a:r>
+            <a:endParaRPr lang="en-US" sz="1700" dirty="0"/>
+          </a:p>
+        </p:txBody>
+      </p:sp>
+      <p:sp>
+        <p:nvSpPr>
+          <p:cNvPr id="13" name="Text 10"/>
+          <p:cNvSpPr txBox="1"/>
+          <p:nvPr/>
+        </p:nvSpPr>
+        <p:spPr>
+          <a:xfrm>
+            <a:off x="457200" y="4526280"/>
+            <a:ext cx="3200400" cy="228600"/>
+          </a:xfrm>
+          <a:prstGeom prst="rect">
+            <a:avLst/>
+          </a:prstGeom>
+          <a:noFill/>
+          <a:ln/>
+        </p:spPr>
+        <p:txBody>
+          <a:bodyPr wrap="square" lIns="0" tIns="0" rIns="0" bIns="0" rtlCol="0" anchor="t"/>
+          <a:lstStyle/>
+          <a:p>
+            <a:pPr indent="0" marL="0">
+              <a:buNone/>
+            </a:pPr>
+            <a:r>
+              <a:rPr lang="en-US" sz="1200" dirty="0">
+                <a:solidFill>
+                  <a:srgbClr val="C9CED3"/>
+                </a:solidFill>
+                <a:latin typeface="Arial" pitchFamily="34" charset="0"/>
+                <a:ea typeface="Arial" pitchFamily="34" charset="-122"/>
+                <a:cs typeface="Arial" pitchFamily="34" charset="-120"/>
+              </a:rPr>
+              <a:t>Cuenta contable relacionada</a:t>
+            </a:r>
+            <a:endParaRPr lang="en-US" sz="1200" dirty="0"/>
+          </a:p>
+        </p:txBody>
+      </p:sp>
+      <p:sp>
+        <p:nvSpPr>
+          <p:cNvPr id="14" name="Text 11"/>
+          <p:cNvSpPr txBox="1"/>
+          <p:nvPr/>
+        </p:nvSpPr>
+        <p:spPr>
+          <a:xfrm>
+            <a:off x="457200" y="4754880"/>
+            <a:ext cx="3291840" cy="274320"/>
+          </a:xfrm>
+          <a:prstGeom prst="rect">
+            <a:avLst/>
+          </a:prstGeom>
+          <a:noFill/>
+          <a:ln/>
+        </p:spPr>
+        <p:txBody>
+          <a:bodyPr wrap="square" lIns="0" tIns="0" rIns="0" bIns="0" rtlCol="0" anchor="t"/>
+          <a:lstStyle/>
+          <a:p>
+            <a:pPr indent="0" marL="0">
+              <a:buNone/>
+            </a:pPr>
+            <a:r>
+              <a:rPr lang="en-US" sz="1400" b="1" dirty="0">
+                <a:solidFill>
+                  <a:srgbClr val="FFFFFF"/>
+                </a:solidFill>
+                <a:latin typeface="Arial" pitchFamily="34" charset="0"/>
+                <a:ea typeface="Arial" pitchFamily="34" charset="-122"/>
+                <a:cs typeface="Arial" pitchFamily="34" charset="-120"/>
+              </a:rPr>
+              <a:t>12102002030 · saldo 10.000,00</a:t>
             </a:r>
             <a:endParaRPr lang="en-US" sz="1400" dirty="0"/>
           </a:p>
@@ -13644,14 +13862,14 @@
       </p:sp>
       <p:sp>
         <p:nvSpPr>
-          <p:cNvPr id="9" name="Text 7"/>
-          <p:cNvSpPr txBox="1"/>
-          <p:nvPr/>
-        </p:nvSpPr>
-        <p:spPr>
-          <a:xfrm>
-            <a:off x="457200" y="3520440"/>
-            <a:ext cx="3200400" cy="228600"/>
+          <p:cNvPr id="15" name="Text 12"/>
+          <p:cNvSpPr txBox="1"/>
+          <p:nvPr/>
+        </p:nvSpPr>
+        <p:spPr>
+          <a:xfrm>
+            <a:off x="457200" y="5029200"/>
+            <a:ext cx="3291840" cy="228600"/>
           </a:xfrm>
           <a:prstGeom prst="rect">
             <a:avLst/>
@@ -13667,162 +13885,6 @@
               <a:buNone/>
             </a:pPr>
             <a:r>
-              <a:rPr lang="en-US" sz="1200" dirty="0">
-                <a:solidFill>
-                  <a:srgbClr val="C9CED3"/>
-                </a:solidFill>
-                <a:latin typeface="Arial" pitchFamily="34" charset="0"/>
-                <a:ea typeface="Arial" pitchFamily="34" charset="-122"/>
-                <a:cs typeface="Arial" pitchFamily="34" charset="-120"/>
-              </a:rPr>
-              <a:t>Matrícula</a:t>
-            </a:r>
-            <a:endParaRPr lang="en-US" sz="1200" dirty="0"/>
-          </a:p>
-        </p:txBody>
-      </p:sp>
-      <p:sp>
-        <p:nvSpPr>
-          <p:cNvPr id="10" name="Text 8"/>
-          <p:cNvSpPr txBox="1"/>
-          <p:nvPr/>
-        </p:nvSpPr>
-        <p:spPr>
-          <a:xfrm>
-            <a:off x="457200" y="3749040"/>
-            <a:ext cx="3291840" cy="320040"/>
-          </a:xfrm>
-          <a:prstGeom prst="rect">
-            <a:avLst/>
-          </a:prstGeom>
-          <a:noFill/>
-          <a:ln/>
-        </p:spPr>
-        <p:txBody>
-          <a:bodyPr wrap="square" lIns="0" tIns="0" rIns="0" bIns="0" rtlCol="0" anchor="t"/>
-          <a:lstStyle/>
-          <a:p>
-            <a:pPr indent="0" marL="0">
-              <a:buNone/>
-            </a:pPr>
-            <a:r>
-              <a:rPr lang="en-US" sz="1700" b="1" dirty="0">
-                <a:solidFill>
-                  <a:srgbClr val="FFFFFF"/>
-                </a:solidFill>
-                <a:latin typeface="Arial" pitchFamily="34" charset="0"/>
-                <a:ea typeface="Arial" pitchFamily="34" charset="-122"/>
-                <a:cs typeface="Arial" pitchFamily="34" charset="-120"/>
-              </a:rPr>
-              <a:t>2.08.1.01.0019611</a:t>
-            </a:r>
-            <a:endParaRPr lang="en-US" sz="1700" dirty="0"/>
-          </a:p>
-        </p:txBody>
-      </p:sp>
-      <p:sp>
-        <p:nvSpPr>
-          <p:cNvPr id="11" name="Text 9"/>
-          <p:cNvSpPr txBox="1"/>
-          <p:nvPr/>
-        </p:nvSpPr>
-        <p:spPr>
-          <a:xfrm>
-            <a:off x="457200" y="4297680"/>
-            <a:ext cx="3200400" cy="228600"/>
-          </a:xfrm>
-          <a:prstGeom prst="rect">
-            <a:avLst/>
-          </a:prstGeom>
-          <a:noFill/>
-          <a:ln/>
-        </p:spPr>
-        <p:txBody>
-          <a:bodyPr wrap="square" lIns="0" tIns="0" rIns="0" bIns="0" rtlCol="0" anchor="t"/>
-          <a:lstStyle/>
-          <a:p>
-            <a:pPr indent="0" marL="0">
-              <a:buNone/>
-            </a:pPr>
-            <a:r>
-              <a:rPr lang="en-US" sz="1200" dirty="0">
-                <a:solidFill>
-                  <a:srgbClr val="C9CED3"/>
-                </a:solidFill>
-                <a:latin typeface="Arial" pitchFamily="34" charset="0"/>
-                <a:ea typeface="Arial" pitchFamily="34" charset="-122"/>
-                <a:cs typeface="Arial" pitchFamily="34" charset="-120"/>
-              </a:rPr>
-              <a:t>Cuenta contable relacionada</a:t>
-            </a:r>
-            <a:endParaRPr lang="en-US" sz="1200" dirty="0"/>
-          </a:p>
-        </p:txBody>
-      </p:sp>
-      <p:sp>
-        <p:nvSpPr>
-          <p:cNvPr id="12" name="Text 10"/>
-          <p:cNvSpPr txBox="1"/>
-          <p:nvPr/>
-        </p:nvSpPr>
-        <p:spPr>
-          <a:xfrm>
-            <a:off x="457200" y="4526280"/>
-            <a:ext cx="3291840" cy="274320"/>
-          </a:xfrm>
-          <a:prstGeom prst="rect">
-            <a:avLst/>
-          </a:prstGeom>
-          <a:noFill/>
-          <a:ln/>
-        </p:spPr>
-        <p:txBody>
-          <a:bodyPr wrap="square" lIns="0" tIns="0" rIns="0" bIns="0" rtlCol="0" anchor="t"/>
-          <a:lstStyle/>
-          <a:p>
-            <a:pPr indent="0" marL="0">
-              <a:buNone/>
-            </a:pPr>
-            <a:r>
-              <a:rPr lang="en-US" sz="1400" b="1" dirty="0">
-                <a:solidFill>
-                  <a:srgbClr val="FFFFFF"/>
-                </a:solidFill>
-                <a:latin typeface="Arial" pitchFamily="34" charset="0"/>
-                <a:ea typeface="Arial" pitchFamily="34" charset="-122"/>
-                <a:cs typeface="Arial" pitchFamily="34" charset="-120"/>
-              </a:rPr>
-              <a:t>12102002030 · saldo 10.000,00</a:t>
-            </a:r>
-            <a:endParaRPr lang="en-US" sz="1400" dirty="0"/>
-          </a:p>
-        </p:txBody>
-      </p:sp>
-      <p:sp>
-        <p:nvSpPr>
-          <p:cNvPr id="13" name="Text 11"/>
-          <p:cNvSpPr txBox="1"/>
-          <p:nvPr/>
-        </p:nvSpPr>
-        <p:spPr>
-          <a:xfrm>
-            <a:off x="457200" y="4828032"/>
-            <a:ext cx="3291840" cy="274320"/>
-          </a:xfrm>
-          <a:prstGeom prst="rect">
-            <a:avLst/>
-          </a:prstGeom>
-          <a:noFill/>
-          <a:ln/>
-        </p:spPr>
-        <p:txBody>
-          <a:bodyPr wrap="square" lIns="0" tIns="0" rIns="0" bIns="0" rtlCol="0" anchor="t"/>
-          <a:lstStyle/>
-          <a:p>
-            <a:pPr indent="0" marL="0">
-              <a:buNone/>
-            </a:pPr>
-            <a:r>
               <a:rPr lang="en-US" sz="1100" dirty="0">
                 <a:solidFill>
                   <a:srgbClr val="9AA3AB"/>
@@ -13839,14 +13901,14 @@
       </p:sp>
       <p:sp>
         <p:nvSpPr>
-          <p:cNvPr id="14" name="Shape 12"/>
+          <p:cNvPr id="16" name="Shape 13"/>
           <p:cNvSpPr/>
           <p:nvPr/>
         </p:nvSpPr>
         <p:spPr>
           <a:xfrm>
-            <a:off x="457200" y="5212080"/>
-            <a:ext cx="3108960" cy="1143000"/>
+            <a:off x="457200" y="5394960"/>
+            <a:ext cx="3108960" cy="1051560"/>
           </a:xfrm>
           <a:prstGeom prst="rect">
             <a:avLst/>
@@ -13864,14 +13926,14 @@
       </p:sp>
       <p:sp>
         <p:nvSpPr>
-          <p:cNvPr id="15" name="Text 13"/>
-          <p:cNvSpPr txBox="1"/>
-          <p:nvPr/>
-        </p:nvSpPr>
-        <p:spPr>
-          <a:xfrm>
-            <a:off x="594360" y="5212080"/>
-            <a:ext cx="2834640" cy="1143000"/>
+          <p:cNvPr id="17" name="Text 14"/>
+          <p:cNvSpPr txBox="1"/>
+          <p:nvPr/>
+        </p:nvSpPr>
+        <p:spPr>
+          <a:xfrm>
+            <a:off x="594360" y="5394960"/>
+            <a:ext cx="2834640" cy="1051560"/>
           </a:xfrm>
           <a:prstGeom prst="rect">
             <a:avLst/>
@@ -13885,7 +13947,7 @@
           <a:p>
             <a:pPr indent="0" marL="0">
               <a:spcAft>
-                <a:spcPts val="600"/>
+                <a:spcPts val="500"/>
               </a:spcAft>
               <a:buNone/>
             </a:pPr>
@@ -13923,7 +13985,7 @@
       </p:sp>
       <p:sp>
         <p:nvSpPr>
-          <p:cNvPr id="16" name="Text 14"/>
+          <p:cNvPr id="18" name="Text 15"/>
           <p:cNvSpPr txBox="1"/>
           <p:nvPr/>
         </p:nvSpPr>
@@ -13962,7 +14024,7 @@
       </p:sp>
       <p:sp>
         <p:nvSpPr>
-          <p:cNvPr id="17" name="Text 15"/>
+          <p:cNvPr id="19" name="Text 16"/>
           <p:cNvSpPr txBox="1"/>
           <p:nvPr/>
         </p:nvSpPr>
@@ -14001,7 +14063,7 @@
       </p:sp>
       <p:sp>
         <p:nvSpPr>
-          <p:cNvPr id="18" name="Marca dorada"/>
+          <p:cNvPr id="20" name="Marca dorada"/>
           <p:cNvSpPr/>
           <p:nvPr/>
         </p:nvSpPr>
@@ -14026,7 +14088,7 @@
       </p:sp>
       <p:sp>
         <p:nvSpPr>
-          <p:cNvPr id="19" name="Text 17"/>
+          <p:cNvPr id="21" name="Text 18"/>
           <p:cNvSpPr txBox="1"/>
           <p:nvPr/>
         </p:nvSpPr>
@@ -14065,7 +14127,7 @@
       </p:sp>
       <p:sp>
         <p:nvSpPr>
-          <p:cNvPr id="20" name="Text 18"/>
+          <p:cNvPr id="22" name="Text 19"/>
           <p:cNvSpPr txBox="1"/>
           <p:nvPr/>
         </p:nvSpPr>
@@ -14104,7 +14166,7 @@
       </p:sp>
       <p:graphicFrame>
         <p:nvGraphicFramePr>
-          <p:cNvPr id="21" name="Chart 0" descr=""/>
+          <p:cNvPr id="23" name="Chart 0" descr=""/>
           <p:cNvGraphicFramePr/>
           <p:nvPr/>
         </p:nvGraphicFramePr>
@@ -14114,13 +14176,13 @@
         </p:xfrm>
         <a:graphic xmlns:a="http://schemas.openxmlformats.org/drawingml/2006/main">
           <a:graphicData uri="http://schemas.openxmlformats.org/drawingml/2006/chart">
-            <c:chart xmlns:c="http://schemas.openxmlformats.org/drawingml/2006/chart" r:id="rId1"/>
+            <c:chart xmlns:c="http://schemas.openxmlformats.org/drawingml/2006/chart" r:id="rId2"/>
           </a:graphicData>
         </a:graphic>
       </p:graphicFrame>
       <p:sp>
         <p:nvSpPr>
-          <p:cNvPr id="22" name="Text 19"/>
+          <p:cNvPr id="24" name="Text 20"/>
           <p:cNvSpPr txBox="1"/>
           <p:nvPr/>
         </p:nvSpPr>
@@ -14159,7 +14221,7 @@
       </p:sp>
       <p:sp>
         <p:nvSpPr>
-          <p:cNvPr id="23" name="Shape 20"/>
+          <p:cNvPr id="25" name="Shape 21"/>
           <p:cNvSpPr/>
           <p:nvPr/>
         </p:nvSpPr>
@@ -14184,7 +14246,7 @@
       </p:sp>
       <p:sp>
         <p:nvSpPr>
-          <p:cNvPr id="24" name="Text 21"/>
+          <p:cNvPr id="26" name="Text 22"/>
           <p:cNvSpPr txBox="1"/>
           <p:nvPr/>
         </p:nvSpPr>
@@ -14223,7 +14285,7 @@
       </p:sp>
       <p:sp>
         <p:nvSpPr>
-          <p:cNvPr id="25" name="Text 22"/>
+          <p:cNvPr id="27" name="Text 23"/>
           <p:cNvSpPr txBox="1"/>
           <p:nvPr/>
         </p:nvSpPr>
@@ -14262,7 +14324,7 @@
       </p:sp>
       <p:sp>
         <p:nvSpPr>
-          <p:cNvPr id="26" name="Shape 23"/>
+          <p:cNvPr id="28" name="Shape 24"/>
           <p:cNvSpPr/>
           <p:nvPr/>
         </p:nvSpPr>
@@ -14287,7 +14349,7 @@
       </p:sp>
       <p:sp>
         <p:nvSpPr>
-          <p:cNvPr id="27" name="Text 24"/>
+          <p:cNvPr id="29" name="Text 25"/>
           <p:cNvSpPr txBox="1"/>
           <p:nvPr/>
         </p:nvSpPr>
@@ -14326,7 +14388,7 @@
       </p:sp>
       <p:sp>
         <p:nvSpPr>
-          <p:cNvPr id="28" name="Text 25"/>
+          <p:cNvPr id="30" name="Text 26"/>
           <p:cNvSpPr txBox="1"/>
           <p:nvPr/>
         </p:nvSpPr>
@@ -14365,7 +14427,7 @@
       </p:sp>
       <p:sp>
         <p:nvSpPr>
-          <p:cNvPr id="29" name="Tarjeta DOS GRAVÁMENES"/>
+          <p:cNvPr id="31" name="Tarjeta DOS GRAVÁMENES"/>
           <p:cNvSpPr/>
           <p:nvPr/>
         </p:nvSpPr>
@@ -14397,7 +14459,7 @@
       </p:sp>
       <p:sp>
         <p:nvSpPr>
-          <p:cNvPr id="30" name="Shape 27"/>
+          <p:cNvPr id="32" name="Shape 28"/>
           <p:cNvSpPr/>
           <p:nvPr/>
         </p:nvSpPr>
@@ -14422,7 +14484,7 @@
       </p:sp>
       <p:sp>
         <p:nvSpPr>
-          <p:cNvPr id="31" name="Text 28"/>
+          <p:cNvPr id="33" name="Text 29"/>
           <p:cNvSpPr txBox="1"/>
           <p:nvPr/>
         </p:nvSpPr>
@@ -14461,7 +14523,7 @@
       </p:sp>
       <p:sp>
         <p:nvSpPr>
-          <p:cNvPr id="32" name="Text 29"/>
+          <p:cNvPr id="34" name="Text 30"/>
           <p:cNvSpPr txBox="1"/>
           <p:nvPr/>
         </p:nvSpPr>
@@ -14500,7 +14562,7 @@
       </p:sp>
       <p:sp>
         <p:nvSpPr>
-          <p:cNvPr id="33" name="Tarjeta LECTURA DE LA CUOTA"/>
+          <p:cNvPr id="35" name="Tarjeta LECTURA DE LA CUOTA"/>
           <p:cNvSpPr/>
           <p:nvPr/>
         </p:nvSpPr>
@@ -14532,7 +14594,7 @@
       </p:sp>
       <p:sp>
         <p:nvSpPr>
-          <p:cNvPr id="34" name="Shape 31"/>
+          <p:cNvPr id="36" name="Shape 32"/>
           <p:cNvSpPr/>
           <p:nvPr/>
         </p:nvSpPr>
@@ -14557,7 +14619,7 @@
       </p:sp>
       <p:sp>
         <p:nvSpPr>
-          <p:cNvPr id="35" name="Text 32"/>
+          <p:cNvPr id="37" name="Text 33"/>
           <p:cNvSpPr txBox="1"/>
           <p:nvPr/>
         </p:nvSpPr>
@@ -14596,7 +14658,7 @@
       </p:sp>
       <p:sp>
         <p:nvSpPr>
-          <p:cNvPr id="36" name="Text 33"/>
+          <p:cNvPr id="38" name="Text 34"/>
           <p:cNvSpPr txBox="1"/>
           <p:nvPr/>
         </p:nvSpPr>
@@ -14635,7 +14697,7 @@
       </p:sp>
       <p:sp>
         <p:nvSpPr>
-          <p:cNvPr id="37" name="Text 34"/>
+          <p:cNvPr id="39" name="Text 35"/>
           <p:cNvSpPr txBox="1"/>
           <p:nvPr/>
         </p:nvSpPr>
@@ -14770,16 +14832,39 @@
           </a:ln>
         </p:spPr>
       </p:sp>
-      <p:sp>
-        <p:nvSpPr>
-          <p:cNvPr id="3" name="Etiqueta"/>
+      <p:pic>
+        <p:nvPicPr>
+          <p:cNvPr id="3" name="Image 0" descr="Mapa referencial de la zona Mamani y la ciudad de Viacha">    </p:cNvPr>
+          <p:cNvPicPr>
+            <a:picLocks noChangeAspect="1"/>
+          </p:cNvPicPr>
+          <p:nvPr/>
+        </p:nvPicPr>
+        <p:blipFill>
+          <a:blip r:embed="rId1"/>
+          <a:srcRect l="0" r="0" t="0" b="0"/>
+          <a:stretch/>
+        </p:blipFill>
+        <p:spPr>
+          <a:xfrm>
+            <a:off x="0" y="0"/>
+            <a:ext cx="4023360" cy="2651760"/>
+          </a:xfrm>
+          <a:prstGeom prst="rect">
+            <a:avLst/>
+          </a:prstGeom>
+        </p:spPr>
+      </p:pic>
+      <p:sp>
+        <p:nvSpPr>
+          <p:cNvPr id="4" name="Etiqueta"/>
           <p:cNvSpPr/>
           <p:nvPr/>
         </p:nvSpPr>
         <p:spPr>
           <a:xfrm>
-            <a:off x="457200" y="457200"/>
-            <a:ext cx="3108960" cy="822960"/>
+            <a:off x="274320" y="274320"/>
+            <a:ext cx="2286000" cy="731520"/>
           </a:xfrm>
           <a:prstGeom prst="rect">
             <a:avLst/>
@@ -14797,14 +14882,14 @@
       </p:sp>
       <p:sp>
         <p:nvSpPr>
-          <p:cNvPr id="4" name="Etiqueta barra"/>
+          <p:cNvPr id="5" name="Etiqueta barra"/>
           <p:cNvSpPr/>
           <p:nvPr/>
         </p:nvSpPr>
         <p:spPr>
           <a:xfrm>
-            <a:off x="457200" y="457200"/>
-            <a:ext cx="64008" cy="822960"/>
+            <a:off x="274320" y="274320"/>
+            <a:ext cx="64008" cy="731520"/>
           </a:xfrm>
           <a:prstGeom prst="rect">
             <a:avLst/>
@@ -14822,14 +14907,14 @@
       </p:sp>
       <p:sp>
         <p:nvSpPr>
-          <p:cNvPr id="5" name="Text 3"/>
-          <p:cNvSpPr txBox="1"/>
-          <p:nvPr/>
-        </p:nvSpPr>
-        <p:spPr>
-          <a:xfrm>
-            <a:off x="731520" y="457200"/>
-            <a:ext cx="2743200" cy="822960"/>
+          <p:cNvPr id="6" name="Text 3"/>
+          <p:cNvSpPr txBox="1"/>
+          <p:nvPr/>
+        </p:nvSpPr>
+        <p:spPr>
+          <a:xfrm>
+            <a:off x="548640" y="274320"/>
+            <a:ext cx="1920240" cy="731520"/>
           </a:xfrm>
           <a:prstGeom prst="rect">
             <a:avLst/>
@@ -14845,7 +14930,7 @@
               <a:buNone/>
             </a:pPr>
             <a:r>
-              <a:rPr lang="en-US" sz="1300" dirty="0">
+              <a:rPr lang="en-US" sz="1200" dirty="0">
                 <a:solidFill>
                   <a:srgbClr val="FFFFFF"/>
                 </a:solidFill>
@@ -14862,7 +14947,7 @@
               <a:buNone/>
             </a:pPr>
             <a:r>
-              <a:rPr lang="en-US" sz="1800" b="1" dirty="0">
+              <a:rPr lang="en-US" sz="1600" b="1" dirty="0">
                 <a:solidFill>
                   <a:srgbClr val="FFFFFF"/>
                 </a:solidFill>
@@ -14878,13 +14963,77 @@
       </p:sp>
       <p:sp>
         <p:nvSpPr>
-          <p:cNvPr id="6" name="Text 4"/>
-          <p:cNvSpPr txBox="1"/>
-          <p:nvPr/>
-        </p:nvSpPr>
-        <p:spPr>
-          <a:xfrm>
-            <a:off x="457200" y="1737360"/>
+          <p:cNvPr id="7" name="Shape 4"/>
+          <p:cNvSpPr/>
+          <p:nvPr/>
+        </p:nvSpPr>
+        <p:spPr>
+          <a:xfrm>
+            <a:off x="0" y="2286000"/>
+            <a:ext cx="4023360" cy="365760"/>
+          </a:xfrm>
+          <a:prstGeom prst="rect">
+            <a:avLst/>
+          </a:prstGeom>
+          <a:solidFill>
+            <a:srgbClr val="1B2126"/>
+          </a:solidFill>
+          <a:ln w="12700">
+            <a:solidFill>
+              <a:srgbClr val="1B2126"/>
+            </a:solidFill>
+            <a:prstDash val="solid"/>
+          </a:ln>
+        </p:spPr>
+      </p:sp>
+      <p:sp>
+        <p:nvSpPr>
+          <p:cNvPr id="8" name="Text 5"/>
+          <p:cNvSpPr txBox="1"/>
+          <p:nvPr/>
+        </p:nvSpPr>
+        <p:spPr>
+          <a:xfrm>
+            <a:off x="274320" y="2286000"/>
+            <a:ext cx="3657600" cy="365760"/>
+          </a:xfrm>
+          <a:prstGeom prst="rect">
+            <a:avLst/>
+          </a:prstGeom>
+          <a:noFill/>
+          <a:ln/>
+        </p:spPr>
+        <p:txBody>
+          <a:bodyPr wrap="square" lIns="0" tIns="0" rIns="0" bIns="0" rtlCol="0" anchor="ctr"/>
+          <a:lstStyle/>
+          <a:p>
+            <a:pPr indent="0" marL="0">
+              <a:buNone/>
+            </a:pPr>
+            <a:r>
+              <a:rPr lang="en-US" sz="900" b="1" spc="50" kern="0" dirty="0">
+                <a:solidFill>
+                  <a:srgbClr val="FFFFFF"/>
+                </a:solidFill>
+                <a:latin typeface="Arial" pitchFamily="34" charset="0"/>
+                <a:ea typeface="Arial" pitchFamily="34" charset="-122"/>
+                <a:cs typeface="Arial" pitchFamily="34" charset="-120"/>
+              </a:rPr>
+              <a:t>UBICACIÓN REFERENCIAL · NO DELIMITA EL PREDIO</a:t>
+            </a:r>
+            <a:endParaRPr lang="en-US" sz="900" dirty="0"/>
+          </a:p>
+        </p:txBody>
+      </p:sp>
+      <p:sp>
+        <p:nvSpPr>
+          <p:cNvPr id="9" name="Text 6"/>
+          <p:cNvSpPr txBox="1"/>
+          <p:nvPr/>
+        </p:nvSpPr>
+        <p:spPr>
+          <a:xfrm>
+            <a:off x="457200" y="2834640"/>
             <a:ext cx="3200400" cy="274320"/>
           </a:xfrm>
           <a:prstGeom prst="rect">
@@ -14917,14 +15066,14 @@
       </p:sp>
       <p:sp>
         <p:nvSpPr>
-          <p:cNvPr id="7" name="Text 5"/>
-          <p:cNvSpPr txBox="1"/>
-          <p:nvPr/>
-        </p:nvSpPr>
-        <p:spPr>
-          <a:xfrm>
-            <a:off x="457200" y="2011680"/>
-            <a:ext cx="3291840" cy="868680"/>
+          <p:cNvPr id="10" name="Text 7"/>
+          <p:cNvSpPr txBox="1"/>
+          <p:nvPr/>
+        </p:nvSpPr>
+        <p:spPr>
+          <a:xfrm>
+            <a:off x="457200" y="3108960"/>
+            <a:ext cx="3383280" cy="685800"/>
           </a:xfrm>
           <a:prstGeom prst="rect">
             <a:avLst/>
@@ -14940,7 +15089,7 @@
               <a:buNone/>
             </a:pPr>
             <a:r>
-              <a:rPr lang="en-US" sz="5400" b="1" dirty="0">
+              <a:rPr lang="en-US" sz="4400" b="1" dirty="0">
                 <a:solidFill>
                   <a:srgbClr val="FFFFFF"/>
                 </a:solidFill>
@@ -14950,20 +15099,34 @@
               </a:rPr>
               <a:t>13,3570</a:t>
             </a:r>
-            <a:endParaRPr lang="en-US" sz="5400" dirty="0"/>
-          </a:p>
-        </p:txBody>
-      </p:sp>
-      <p:sp>
-        <p:nvSpPr>
-          <p:cNvPr id="8" name="Text 6"/>
-          <p:cNvSpPr txBox="1"/>
-          <p:nvPr/>
-        </p:nvSpPr>
-        <p:spPr>
-          <a:xfrm>
-            <a:off x="457200" y="2880360"/>
-            <a:ext cx="3200400" cy="274320"/>
+            <a:pPr indent="0" marL="0">
+              <a:buNone/>
+            </a:pPr>
+            <a:r>
+              <a:rPr lang="en-US" sz="1600" dirty="0">
+                <a:solidFill>
+                  <a:srgbClr val="C9CED3"/>
+                </a:solidFill>
+                <a:latin typeface="Arial" pitchFamily="34" charset="0"/>
+                <a:ea typeface="Arial" pitchFamily="34" charset="-122"/>
+                <a:cs typeface="Arial" pitchFamily="34" charset="-120"/>
+              </a:rPr>
+              <a:t>  ha</a:t>
+            </a:r>
+            <a:endParaRPr lang="en-US" sz="1400" dirty="0"/>
+          </a:p>
+        </p:txBody>
+      </p:sp>
+      <p:sp>
+        <p:nvSpPr>
+          <p:cNvPr id="11" name="Text 8"/>
+          <p:cNvSpPr txBox="1"/>
+          <p:nvPr/>
+        </p:nvSpPr>
+        <p:spPr>
+          <a:xfrm>
+            <a:off x="457200" y="3931920"/>
+            <a:ext cx="3200400" cy="228600"/>
           </a:xfrm>
           <a:prstGeom prst="rect">
             <a:avLst/>
@@ -14979,7 +15142,7 @@
               <a:buNone/>
             </a:pPr>
             <a:r>
-              <a:rPr lang="en-US" sz="1400" dirty="0">
+              <a:rPr lang="en-US" sz="1200" dirty="0">
                 <a:solidFill>
                   <a:srgbClr val="C9CED3"/>
                 </a:solidFill>
@@ -14987,22 +15150,22 @@
                 <a:ea typeface="Arial" pitchFamily="34" charset="-122"/>
                 <a:cs typeface="Arial" pitchFamily="34" charset="-120"/>
               </a:rPr>
-              <a:t>hectáreas</a:t>
-            </a:r>
-            <a:endParaRPr lang="en-US" sz="1400" dirty="0"/>
-          </a:p>
-        </p:txBody>
-      </p:sp>
-      <p:sp>
-        <p:nvSpPr>
-          <p:cNvPr id="9" name="Text 7"/>
-          <p:cNvSpPr txBox="1"/>
-          <p:nvPr/>
-        </p:nvSpPr>
-        <p:spPr>
-          <a:xfrm>
-            <a:off x="457200" y="3520440"/>
-            <a:ext cx="3200400" cy="228600"/>
+              <a:t>Testimonio citado</a:t>
+            </a:r>
+            <a:endParaRPr lang="en-US" sz="1200" dirty="0"/>
+          </a:p>
+        </p:txBody>
+      </p:sp>
+      <p:sp>
+        <p:nvSpPr>
+          <p:cNvPr id="12" name="Text 9"/>
+          <p:cNvSpPr txBox="1"/>
+          <p:nvPr/>
+        </p:nvSpPr>
+        <p:spPr>
+          <a:xfrm>
+            <a:off x="457200" y="4160520"/>
+            <a:ext cx="3291840" cy="365760"/>
           </a:xfrm>
           <a:prstGeom prst="rect">
             <a:avLst/>
@@ -15018,45 +15181,6 @@
               <a:buNone/>
             </a:pPr>
             <a:r>
-              <a:rPr lang="en-US" sz="1200" dirty="0">
-                <a:solidFill>
-                  <a:srgbClr val="C9CED3"/>
-                </a:solidFill>
-                <a:latin typeface="Arial" pitchFamily="34" charset="0"/>
-                <a:ea typeface="Arial" pitchFamily="34" charset="-122"/>
-                <a:cs typeface="Arial" pitchFamily="34" charset="-120"/>
-              </a:rPr>
-              <a:t>Testimonio citado</a:t>
-            </a:r>
-            <a:endParaRPr lang="en-US" sz="1200" dirty="0"/>
-          </a:p>
-        </p:txBody>
-      </p:sp>
-      <p:sp>
-        <p:nvSpPr>
-          <p:cNvPr id="10" name="Text 8"/>
-          <p:cNvSpPr txBox="1"/>
-          <p:nvPr/>
-        </p:nvSpPr>
-        <p:spPr>
-          <a:xfrm>
-            <a:off x="457200" y="3749040"/>
-            <a:ext cx="3291840" cy="365760"/>
-          </a:xfrm>
-          <a:prstGeom prst="rect">
-            <a:avLst/>
-          </a:prstGeom>
-          <a:noFill/>
-          <a:ln/>
-        </p:spPr>
-        <p:txBody>
-          <a:bodyPr wrap="square" lIns="0" tIns="0" rIns="0" bIns="0" rtlCol="0" anchor="t"/>
-          <a:lstStyle/>
-          <a:p>
-            <a:pPr indent="0" marL="0">
-              <a:buNone/>
-            </a:pPr>
-            <a:r>
               <a:rPr lang="en-US" sz="2200" b="1" dirty="0">
                 <a:solidFill>
                   <a:srgbClr val="FFFFFF"/>
@@ -15073,14 +15197,14 @@
       </p:sp>
       <p:sp>
         <p:nvSpPr>
-          <p:cNvPr id="11" name="Shape 9"/>
+          <p:cNvPr id="13" name="Shape 10"/>
           <p:cNvSpPr/>
           <p:nvPr/>
         </p:nvSpPr>
         <p:spPr>
           <a:xfrm>
-            <a:off x="457200" y="4434840"/>
-            <a:ext cx="3108960" cy="1828800"/>
+            <a:off x="457200" y="4754880"/>
+            <a:ext cx="3108960" cy="1600200"/>
           </a:xfrm>
           <a:prstGeom prst="rect">
             <a:avLst/>
@@ -15098,14 +15222,14 @@
       </p:sp>
       <p:sp>
         <p:nvSpPr>
-          <p:cNvPr id="12" name="Text 10"/>
-          <p:cNvSpPr txBox="1"/>
-          <p:nvPr/>
-        </p:nvSpPr>
-        <p:spPr>
-          <a:xfrm>
-            <a:off x="640080" y="4526280"/>
-            <a:ext cx="2743200" cy="1645920"/>
+          <p:cNvPr id="14" name="Text 11"/>
+          <p:cNvSpPr txBox="1"/>
+          <p:nvPr/>
+        </p:nvSpPr>
+        <p:spPr>
+          <a:xfrm>
+            <a:off x="640080" y="4754880"/>
+            <a:ext cx="2743200" cy="1600200"/>
           </a:xfrm>
           <a:prstGeom prst="rect">
             <a:avLst/>
@@ -15137,7 +15261,7 @@
       </p:sp>
       <p:sp>
         <p:nvSpPr>
-          <p:cNvPr id="13" name="Text 11"/>
+          <p:cNvPr id="15" name="Text 12"/>
           <p:cNvSpPr txBox="1"/>
           <p:nvPr/>
         </p:nvSpPr>
@@ -15176,7 +15300,7 @@
       </p:sp>
       <p:sp>
         <p:nvSpPr>
-          <p:cNvPr id="14" name="Text 12"/>
+          <p:cNvPr id="16" name="Text 13"/>
           <p:cNvSpPr txBox="1"/>
           <p:nvPr/>
         </p:nvSpPr>
@@ -15215,7 +15339,7 @@
       </p:sp>
       <p:sp>
         <p:nvSpPr>
-          <p:cNvPr id="15" name="Marca dorada"/>
+          <p:cNvPr id="17" name="Marca dorada"/>
           <p:cNvSpPr/>
           <p:nvPr/>
         </p:nvSpPr>
@@ -15240,7 +15364,7 @@
       </p:sp>
       <p:sp>
         <p:nvSpPr>
-          <p:cNvPr id="16" name="Text 14"/>
+          <p:cNvPr id="18" name="Text 15"/>
           <p:cNvSpPr txBox="1"/>
           <p:nvPr/>
         </p:nvSpPr>
@@ -15279,7 +15403,7 @@
       </p:sp>
       <p:sp>
         <p:nvSpPr>
-          <p:cNvPr id="17" name="Text 15"/>
+          <p:cNvPr id="19" name="Text 16"/>
           <p:cNvSpPr txBox="1"/>
           <p:nvPr/>
         </p:nvSpPr>
@@ -15318,7 +15442,7 @@
       </p:sp>
       <p:sp>
         <p:nvSpPr>
-          <p:cNvPr id="18" name="Shape 16"/>
+          <p:cNvPr id="20" name="Shape 17"/>
           <p:cNvSpPr/>
           <p:nvPr/>
         </p:nvSpPr>
@@ -15343,7 +15467,7 @@
       </p:sp>
       <p:sp>
         <p:nvSpPr>
-          <p:cNvPr id="19" name="Text 17"/>
+          <p:cNvPr id="21" name="Text 18"/>
           <p:cNvSpPr txBox="1"/>
           <p:nvPr/>
         </p:nvSpPr>
@@ -15382,7 +15506,7 @@
       </p:sp>
       <p:sp>
         <p:nvSpPr>
-          <p:cNvPr id="20" name="Shape 18"/>
+          <p:cNvPr id="22" name="Shape 19"/>
           <p:cNvSpPr/>
           <p:nvPr/>
         </p:nvSpPr>
@@ -15407,7 +15531,7 @@
       </p:sp>
       <p:sp>
         <p:nvSpPr>
-          <p:cNvPr id="21" name="Shape 19"/>
+          <p:cNvPr id="23" name="Shape 20"/>
           <p:cNvSpPr/>
           <p:nvPr/>
         </p:nvSpPr>
@@ -15432,7 +15556,7 @@
       </p:sp>
       <p:sp>
         <p:nvSpPr>
-          <p:cNvPr id="22" name="Text 20"/>
+          <p:cNvPr id="24" name="Text 21"/>
           <p:cNvSpPr txBox="1"/>
           <p:nvPr/>
         </p:nvSpPr>
@@ -15471,7 +15595,7 @@
       </p:sp>
       <p:sp>
         <p:nvSpPr>
-          <p:cNvPr id="23" name="Shape 21"/>
+          <p:cNvPr id="25" name="Shape 22"/>
           <p:cNvSpPr/>
           <p:nvPr/>
         </p:nvSpPr>
@@ -15496,7 +15620,7 @@
       </p:sp>
       <p:sp>
         <p:nvSpPr>
-          <p:cNvPr id="24" name="Text 22"/>
+          <p:cNvPr id="26" name="Text 23"/>
           <p:cNvSpPr txBox="1"/>
           <p:nvPr/>
         </p:nvSpPr>
@@ -15535,7 +15659,7 @@
       </p:sp>
       <p:sp>
         <p:nvSpPr>
-          <p:cNvPr id="25" name="Shape 23"/>
+          <p:cNvPr id="27" name="Shape 24"/>
           <p:cNvSpPr/>
           <p:nvPr/>
         </p:nvSpPr>
@@ -15560,7 +15684,7 @@
       </p:sp>
       <p:sp>
         <p:nvSpPr>
-          <p:cNvPr id="26" name="Shape 24"/>
+          <p:cNvPr id="28" name="Shape 25"/>
           <p:cNvSpPr/>
           <p:nvPr/>
         </p:nvSpPr>
@@ -15585,7 +15709,7 @@
       </p:sp>
       <p:sp>
         <p:nvSpPr>
-          <p:cNvPr id="27" name="Text 25"/>
+          <p:cNvPr id="29" name="Text 26"/>
           <p:cNvSpPr txBox="1"/>
           <p:nvPr/>
         </p:nvSpPr>
@@ -15624,7 +15748,7 @@
       </p:sp>
       <p:sp>
         <p:nvSpPr>
-          <p:cNvPr id="28" name="Shape 26"/>
+          <p:cNvPr id="30" name="Shape 27"/>
           <p:cNvSpPr/>
           <p:nvPr/>
         </p:nvSpPr>
@@ -15649,7 +15773,7 @@
       </p:sp>
       <p:sp>
         <p:nvSpPr>
-          <p:cNvPr id="29" name="Text 27"/>
+          <p:cNvPr id="31" name="Text 28"/>
           <p:cNvSpPr txBox="1"/>
           <p:nvPr/>
         </p:nvSpPr>
@@ -15688,7 +15812,7 @@
       </p:sp>
       <p:sp>
         <p:nvSpPr>
-          <p:cNvPr id="30" name="Shape 28"/>
+          <p:cNvPr id="32" name="Shape 29"/>
           <p:cNvSpPr/>
           <p:nvPr/>
         </p:nvSpPr>
@@ -15713,7 +15837,7 @@
       </p:sp>
       <p:sp>
         <p:nvSpPr>
-          <p:cNvPr id="31" name="Shape 29"/>
+          <p:cNvPr id="33" name="Shape 30"/>
           <p:cNvSpPr/>
           <p:nvPr/>
         </p:nvSpPr>
@@ -15738,7 +15862,7 @@
       </p:sp>
       <p:sp>
         <p:nvSpPr>
-          <p:cNvPr id="32" name="Text 30"/>
+          <p:cNvPr id="34" name="Text 31"/>
           <p:cNvSpPr txBox="1"/>
           <p:nvPr/>
         </p:nvSpPr>
@@ -15777,7 +15901,7 @@
       </p:sp>
       <p:sp>
         <p:nvSpPr>
-          <p:cNvPr id="33" name="Shape 31"/>
+          <p:cNvPr id="35" name="Shape 32"/>
           <p:cNvSpPr/>
           <p:nvPr/>
         </p:nvSpPr>
@@ -15802,7 +15926,7 @@
       </p:sp>
       <p:sp>
         <p:nvSpPr>
-          <p:cNvPr id="34" name="Text 32"/>
+          <p:cNvPr id="36" name="Text 33"/>
           <p:cNvSpPr txBox="1"/>
           <p:nvPr/>
         </p:nvSpPr>
@@ -15841,7 +15965,7 @@
       </p:sp>
       <p:sp>
         <p:nvSpPr>
-          <p:cNvPr id="35" name="Shape 33"/>
+          <p:cNvPr id="37" name="Shape 34"/>
           <p:cNvSpPr/>
           <p:nvPr/>
         </p:nvSpPr>
@@ -15866,7 +15990,7 @@
       </p:sp>
       <p:sp>
         <p:nvSpPr>
-          <p:cNvPr id="36" name="Shape 34"/>
+          <p:cNvPr id="38" name="Shape 35"/>
           <p:cNvSpPr/>
           <p:nvPr/>
         </p:nvSpPr>
@@ -15891,7 +16015,7 @@
       </p:sp>
       <p:sp>
         <p:nvSpPr>
-          <p:cNvPr id="37" name="Text 35"/>
+          <p:cNvPr id="39" name="Text 36"/>
           <p:cNvSpPr txBox="1"/>
           <p:nvPr/>
         </p:nvSpPr>
@@ -15930,7 +16054,7 @@
       </p:sp>
       <p:sp>
         <p:nvSpPr>
-          <p:cNvPr id="38" name="Tarjeta * CÁLCULO ARITMÉTICO"/>
+          <p:cNvPr id="40" name="Tarjeta * CÁLCULO ARITMÉTICO"/>
           <p:cNvSpPr/>
           <p:nvPr/>
         </p:nvSpPr>
@@ -15962,7 +16086,7 @@
       </p:sp>
       <p:sp>
         <p:nvSpPr>
-          <p:cNvPr id="39" name="Shape 37"/>
+          <p:cNvPr id="41" name="Shape 38"/>
           <p:cNvSpPr/>
           <p:nvPr/>
         </p:nvSpPr>
@@ -15987,7 +16111,7 @@
       </p:sp>
       <p:sp>
         <p:nvSpPr>
-          <p:cNvPr id="40" name="Text 38"/>
+          <p:cNvPr id="42" name="Text 39"/>
           <p:cNvSpPr txBox="1"/>
           <p:nvPr/>
         </p:nvSpPr>
@@ -16026,7 +16150,7 @@
       </p:sp>
       <p:sp>
         <p:nvSpPr>
-          <p:cNvPr id="41" name="Text 39"/>
+          <p:cNvPr id="43" name="Text 40"/>
           <p:cNvSpPr txBox="1"/>
           <p:nvPr/>
         </p:nvSpPr>
@@ -16065,7 +16189,7 @@
       </p:sp>
       <p:sp>
         <p:nvSpPr>
-          <p:cNvPr id="42" name="Text 40"/>
+          <p:cNvPr id="44" name="Text 41"/>
           <p:cNvSpPr txBox="1"/>
           <p:nvPr/>
         </p:nvSpPr>
@@ -16200,16 +16324,39 @@
           </a:ln>
         </p:spPr>
       </p:sp>
-      <p:sp>
-        <p:nvSpPr>
-          <p:cNvPr id="3" name="Etiqueta"/>
+      <p:pic>
+        <p:nvPicPr>
+          <p:cNvPr id="3" name="Image 0" descr="Mapa referencial de la zona Mamani y la ciudad de Viacha">    </p:cNvPr>
+          <p:cNvPicPr>
+            <a:picLocks noChangeAspect="1"/>
+          </p:cNvPicPr>
+          <p:nvPr/>
+        </p:nvPicPr>
+        <p:blipFill>
+          <a:blip r:embed="rId1"/>
+          <a:srcRect l="0" r="0" t="0" b="0"/>
+          <a:stretch/>
+        </p:blipFill>
+        <p:spPr>
+          <a:xfrm>
+            <a:off x="0" y="0"/>
+            <a:ext cx="4023360" cy="2651760"/>
+          </a:xfrm>
+          <a:prstGeom prst="rect">
+            <a:avLst/>
+          </a:prstGeom>
+        </p:spPr>
+      </p:pic>
+      <p:sp>
+        <p:nvSpPr>
+          <p:cNvPr id="4" name="Etiqueta"/>
           <p:cNvSpPr/>
           <p:nvPr/>
         </p:nvSpPr>
         <p:spPr>
           <a:xfrm>
-            <a:off x="457200" y="457200"/>
-            <a:ext cx="3108960" cy="822960"/>
+            <a:off x="274320" y="274320"/>
+            <a:ext cx="2286000" cy="731520"/>
           </a:xfrm>
           <a:prstGeom prst="rect">
             <a:avLst/>
@@ -16227,14 +16374,14 @@
       </p:sp>
       <p:sp>
         <p:nvSpPr>
-          <p:cNvPr id="4" name="Etiqueta barra"/>
+          <p:cNvPr id="5" name="Etiqueta barra"/>
           <p:cNvSpPr/>
           <p:nvPr/>
         </p:nvSpPr>
         <p:spPr>
           <a:xfrm>
-            <a:off x="457200" y="457200"/>
-            <a:ext cx="64008" cy="822960"/>
+            <a:off x="274320" y="274320"/>
+            <a:ext cx="64008" cy="731520"/>
           </a:xfrm>
           <a:prstGeom prst="rect">
             <a:avLst/>
@@ -16252,14 +16399,14 @@
       </p:sp>
       <p:sp>
         <p:nvSpPr>
-          <p:cNvPr id="5" name="Text 3"/>
-          <p:cNvSpPr txBox="1"/>
-          <p:nvPr/>
-        </p:nvSpPr>
-        <p:spPr>
-          <a:xfrm>
-            <a:off x="731520" y="457200"/>
-            <a:ext cx="2743200" cy="822960"/>
+          <p:cNvPr id="6" name="Text 3"/>
+          <p:cNvSpPr txBox="1"/>
+          <p:nvPr/>
+        </p:nvSpPr>
+        <p:spPr>
+          <a:xfrm>
+            <a:off x="548640" y="274320"/>
+            <a:ext cx="1920240" cy="731520"/>
           </a:xfrm>
           <a:prstGeom prst="rect">
             <a:avLst/>
@@ -16275,7 +16422,7 @@
               <a:buNone/>
             </a:pPr>
             <a:r>
-              <a:rPr lang="en-US" sz="1300" dirty="0">
+              <a:rPr lang="en-US" sz="1200" dirty="0">
                 <a:solidFill>
                   <a:srgbClr val="FFFFFF"/>
                 </a:solidFill>
@@ -16292,7 +16439,7 @@
               <a:buNone/>
             </a:pPr>
             <a:r>
-              <a:rPr lang="en-US" sz="1800" b="1" dirty="0">
+              <a:rPr lang="en-US" sz="1600" b="1" dirty="0">
                 <a:solidFill>
                   <a:srgbClr val="FFFFFF"/>
                 </a:solidFill>
@@ -16308,13 +16455,77 @@
       </p:sp>
       <p:sp>
         <p:nvSpPr>
-          <p:cNvPr id="6" name="Text 4"/>
-          <p:cNvSpPr txBox="1"/>
-          <p:nvPr/>
-        </p:nvSpPr>
-        <p:spPr>
-          <a:xfrm>
-            <a:off x="457200" y="1737360"/>
+          <p:cNvPr id="7" name="Shape 4"/>
+          <p:cNvSpPr/>
+          <p:nvPr/>
+        </p:nvSpPr>
+        <p:spPr>
+          <a:xfrm>
+            <a:off x="0" y="2286000"/>
+            <a:ext cx="4023360" cy="365760"/>
+          </a:xfrm>
+          <a:prstGeom prst="rect">
+            <a:avLst/>
+          </a:prstGeom>
+          <a:solidFill>
+            <a:srgbClr val="1B2126"/>
+          </a:solidFill>
+          <a:ln w="12700">
+            <a:solidFill>
+              <a:srgbClr val="1B2126"/>
+            </a:solidFill>
+            <a:prstDash val="solid"/>
+          </a:ln>
+        </p:spPr>
+      </p:sp>
+      <p:sp>
+        <p:nvSpPr>
+          <p:cNvPr id="8" name="Text 5"/>
+          <p:cNvSpPr txBox="1"/>
+          <p:nvPr/>
+        </p:nvSpPr>
+        <p:spPr>
+          <a:xfrm>
+            <a:off x="274320" y="2286000"/>
+            <a:ext cx="3657600" cy="365760"/>
+          </a:xfrm>
+          <a:prstGeom prst="rect">
+            <a:avLst/>
+          </a:prstGeom>
+          <a:noFill/>
+          <a:ln/>
+        </p:spPr>
+        <p:txBody>
+          <a:bodyPr wrap="square" lIns="0" tIns="0" rIns="0" bIns="0" rtlCol="0" anchor="ctr"/>
+          <a:lstStyle/>
+          <a:p>
+            <a:pPr indent="0" marL="0">
+              <a:buNone/>
+            </a:pPr>
+            <a:r>
+              <a:rPr lang="en-US" sz="900" b="1" spc="50" kern="0" dirty="0">
+                <a:solidFill>
+                  <a:srgbClr val="FFFFFF"/>
+                </a:solidFill>
+                <a:latin typeface="Arial" pitchFamily="34" charset="0"/>
+                <a:ea typeface="Arial" pitchFamily="34" charset="-122"/>
+                <a:cs typeface="Arial" pitchFamily="34" charset="-120"/>
+              </a:rPr>
+              <a:t>UBICACIÓN REFERENCIAL · NO DELIMITA EL PREDIO</a:t>
+            </a:r>
+            <a:endParaRPr lang="en-US" sz="900" dirty="0"/>
+          </a:p>
+        </p:txBody>
+      </p:sp>
+      <p:sp>
+        <p:nvSpPr>
+          <p:cNvPr id="9" name="Text 6"/>
+          <p:cNvSpPr txBox="1"/>
+          <p:nvPr/>
+        </p:nvSpPr>
+        <p:spPr>
+          <a:xfrm>
+            <a:off x="457200" y="2834640"/>
             <a:ext cx="3200400" cy="274320"/>
           </a:xfrm>
           <a:prstGeom prst="rect">
@@ -16347,14 +16558,14 @@
       </p:sp>
       <p:sp>
         <p:nvSpPr>
-          <p:cNvPr id="7" name="Text 5"/>
-          <p:cNvSpPr txBox="1"/>
-          <p:nvPr/>
-        </p:nvSpPr>
-        <p:spPr>
-          <a:xfrm>
-            <a:off x="457200" y="2011680"/>
-            <a:ext cx="3291840" cy="868680"/>
+          <p:cNvPr id="10" name="Text 7"/>
+          <p:cNvSpPr txBox="1"/>
+          <p:nvPr/>
+        </p:nvSpPr>
+        <p:spPr>
+          <a:xfrm>
+            <a:off x="457200" y="3108960"/>
+            <a:ext cx="3383280" cy="685800"/>
           </a:xfrm>
           <a:prstGeom prst="rect">
             <a:avLst/>
@@ -16370,7 +16581,7 @@
               <a:buNone/>
             </a:pPr>
             <a:r>
-              <a:rPr lang="en-US" sz="5400" b="1" dirty="0">
+              <a:rPr lang="en-US" sz="4400" b="1" dirty="0">
                 <a:solidFill>
                   <a:srgbClr val="FFFFFF"/>
                 </a:solidFill>
@@ -16380,20 +16591,34 @@
               </a:rPr>
               <a:t>18,5512</a:t>
             </a:r>
-            <a:endParaRPr lang="en-US" sz="5400" dirty="0"/>
-          </a:p>
-        </p:txBody>
-      </p:sp>
-      <p:sp>
-        <p:nvSpPr>
-          <p:cNvPr id="8" name="Text 6"/>
-          <p:cNvSpPr txBox="1"/>
-          <p:nvPr/>
-        </p:nvSpPr>
-        <p:spPr>
-          <a:xfrm>
-            <a:off x="457200" y="2880360"/>
-            <a:ext cx="3200400" cy="274320"/>
+            <a:pPr indent="0" marL="0">
+              <a:buNone/>
+            </a:pPr>
+            <a:r>
+              <a:rPr lang="en-US" sz="1600" dirty="0">
+                <a:solidFill>
+                  <a:srgbClr val="C9CED3"/>
+                </a:solidFill>
+                <a:latin typeface="Arial" pitchFamily="34" charset="0"/>
+                <a:ea typeface="Arial" pitchFamily="34" charset="-122"/>
+                <a:cs typeface="Arial" pitchFamily="34" charset="-120"/>
+              </a:rPr>
+              <a:t>  ha</a:t>
+            </a:r>
+            <a:endParaRPr lang="en-US" sz="1400" dirty="0"/>
+          </a:p>
+        </p:txBody>
+      </p:sp>
+      <p:sp>
+        <p:nvSpPr>
+          <p:cNvPr id="11" name="Text 8"/>
+          <p:cNvSpPr txBox="1"/>
+          <p:nvPr/>
+        </p:nvSpPr>
+        <p:spPr>
+          <a:xfrm>
+            <a:off x="457200" y="3931920"/>
+            <a:ext cx="3200400" cy="228600"/>
           </a:xfrm>
           <a:prstGeom prst="rect">
             <a:avLst/>
@@ -16409,7 +16634,7 @@
               <a:buNone/>
             </a:pPr>
             <a:r>
-              <a:rPr lang="en-US" sz="1400" dirty="0">
+              <a:rPr lang="en-US" sz="1200" dirty="0">
                 <a:solidFill>
                   <a:srgbClr val="C9CED3"/>
                 </a:solidFill>
@@ -16417,22 +16642,22 @@
                 <a:ea typeface="Arial" pitchFamily="34" charset="-122"/>
                 <a:cs typeface="Arial" pitchFamily="34" charset="-120"/>
               </a:rPr>
-              <a:t>hectáreas</a:t>
-            </a:r>
-            <a:endParaRPr lang="en-US" sz="1400" dirty="0"/>
-          </a:p>
-        </p:txBody>
-      </p:sp>
-      <p:sp>
-        <p:nvSpPr>
-          <p:cNvPr id="9" name="Text 7"/>
-          <p:cNvSpPr txBox="1"/>
-          <p:nvPr/>
-        </p:nvSpPr>
-        <p:spPr>
-          <a:xfrm>
-            <a:off x="457200" y="3520440"/>
-            <a:ext cx="3200400" cy="228600"/>
+              <a:t>Testimonio citado</a:t>
+            </a:r>
+            <a:endParaRPr lang="en-US" sz="1200" dirty="0"/>
+          </a:p>
+        </p:txBody>
+      </p:sp>
+      <p:sp>
+        <p:nvSpPr>
+          <p:cNvPr id="12" name="Text 9"/>
+          <p:cNvSpPr txBox="1"/>
+          <p:nvPr/>
+        </p:nvSpPr>
+        <p:spPr>
+          <a:xfrm>
+            <a:off x="457200" y="4160520"/>
+            <a:ext cx="3291840" cy="365760"/>
           </a:xfrm>
           <a:prstGeom prst="rect">
             <a:avLst/>
@@ -16448,45 +16673,6 @@
               <a:buNone/>
             </a:pPr>
             <a:r>
-              <a:rPr lang="en-US" sz="1200" dirty="0">
-                <a:solidFill>
-                  <a:srgbClr val="C9CED3"/>
-                </a:solidFill>
-                <a:latin typeface="Arial" pitchFamily="34" charset="0"/>
-                <a:ea typeface="Arial" pitchFamily="34" charset="-122"/>
-                <a:cs typeface="Arial" pitchFamily="34" charset="-120"/>
-              </a:rPr>
-              <a:t>Testimonio citado</a:t>
-            </a:r>
-            <a:endParaRPr lang="en-US" sz="1200" dirty="0"/>
-          </a:p>
-        </p:txBody>
-      </p:sp>
-      <p:sp>
-        <p:nvSpPr>
-          <p:cNvPr id="10" name="Text 8"/>
-          <p:cNvSpPr txBox="1"/>
-          <p:nvPr/>
-        </p:nvSpPr>
-        <p:spPr>
-          <a:xfrm>
-            <a:off x="457200" y="3749040"/>
-            <a:ext cx="3291840" cy="365760"/>
-          </a:xfrm>
-          <a:prstGeom prst="rect">
-            <a:avLst/>
-          </a:prstGeom>
-          <a:noFill/>
-          <a:ln/>
-        </p:spPr>
-        <p:txBody>
-          <a:bodyPr wrap="square" lIns="0" tIns="0" rIns="0" bIns="0" rtlCol="0" anchor="t"/>
-          <a:lstStyle/>
-          <a:p>
-            <a:pPr indent="0" marL="0">
-              <a:buNone/>
-            </a:pPr>
-            <a:r>
               <a:rPr lang="en-US" sz="2200" b="1" dirty="0">
                 <a:solidFill>
                   <a:srgbClr val="FFFFFF"/>
@@ -16503,14 +16689,14 @@
       </p:sp>
       <p:sp>
         <p:nvSpPr>
-          <p:cNvPr id="11" name="Shape 9"/>
+          <p:cNvPr id="13" name="Shape 10"/>
           <p:cNvSpPr/>
           <p:nvPr/>
         </p:nvSpPr>
         <p:spPr>
           <a:xfrm>
-            <a:off x="457200" y="4434840"/>
-            <a:ext cx="3108960" cy="1828800"/>
+            <a:off x="457200" y="4754880"/>
+            <a:ext cx="3108960" cy="1600200"/>
           </a:xfrm>
           <a:prstGeom prst="rect">
             <a:avLst/>
@@ -16528,14 +16714,14 @@
       </p:sp>
       <p:sp>
         <p:nvSpPr>
-          <p:cNvPr id="12" name="Text 10"/>
-          <p:cNvSpPr txBox="1"/>
-          <p:nvPr/>
-        </p:nvSpPr>
-        <p:spPr>
-          <a:xfrm>
-            <a:off x="640080" y="4526280"/>
-            <a:ext cx="2743200" cy="1645920"/>
+          <p:cNvPr id="14" name="Text 11"/>
+          <p:cNvSpPr txBox="1"/>
+          <p:nvPr/>
+        </p:nvSpPr>
+        <p:spPr>
+          <a:xfrm>
+            <a:off x="640080" y="4754880"/>
+            <a:ext cx="2743200" cy="1600200"/>
           </a:xfrm>
           <a:prstGeom prst="rect">
             <a:avLst/>
@@ -16567,7 +16753,7 @@
       </p:sp>
       <p:sp>
         <p:nvSpPr>
-          <p:cNvPr id="13" name="Text 11"/>
+          <p:cNvPr id="15" name="Text 12"/>
           <p:cNvSpPr txBox="1"/>
           <p:nvPr/>
         </p:nvSpPr>
@@ -16606,7 +16792,7 @@
       </p:sp>
       <p:sp>
         <p:nvSpPr>
-          <p:cNvPr id="14" name="Text 12"/>
+          <p:cNvPr id="16" name="Text 13"/>
           <p:cNvSpPr txBox="1"/>
           <p:nvPr/>
         </p:nvSpPr>
@@ -16645,7 +16831,7 @@
       </p:sp>
       <p:sp>
         <p:nvSpPr>
-          <p:cNvPr id="15" name="Marca dorada"/>
+          <p:cNvPr id="17" name="Marca dorada"/>
           <p:cNvSpPr/>
           <p:nvPr/>
         </p:nvSpPr>
@@ -16670,7 +16856,7 @@
       </p:sp>
       <p:sp>
         <p:nvSpPr>
-          <p:cNvPr id="16" name="Text 14"/>
+          <p:cNvPr id="18" name="Text 15"/>
           <p:cNvSpPr txBox="1"/>
           <p:nvPr/>
         </p:nvSpPr>
@@ -16709,7 +16895,7 @@
       </p:sp>
       <p:sp>
         <p:nvSpPr>
-          <p:cNvPr id="17" name="Text 15"/>
+          <p:cNvPr id="19" name="Text 16"/>
           <p:cNvSpPr txBox="1"/>
           <p:nvPr/>
         </p:nvSpPr>
@@ -16748,7 +16934,7 @@
       </p:sp>
       <p:sp>
         <p:nvSpPr>
-          <p:cNvPr id="18" name="Shape 16"/>
+          <p:cNvPr id="20" name="Shape 17"/>
           <p:cNvSpPr/>
           <p:nvPr/>
         </p:nvSpPr>
@@ -16773,7 +16959,7 @@
       </p:sp>
       <p:sp>
         <p:nvSpPr>
-          <p:cNvPr id="19" name="Text 17"/>
+          <p:cNvPr id="21" name="Text 18"/>
           <p:cNvSpPr txBox="1"/>
           <p:nvPr/>
         </p:nvSpPr>
@@ -16812,7 +16998,7 @@
       </p:sp>
       <p:sp>
         <p:nvSpPr>
-          <p:cNvPr id="20" name="Shape 18"/>
+          <p:cNvPr id="22" name="Shape 19"/>
           <p:cNvSpPr/>
           <p:nvPr/>
         </p:nvSpPr>
@@ -16837,7 +17023,7 @@
       </p:sp>
       <p:sp>
         <p:nvSpPr>
-          <p:cNvPr id="21" name="Shape 19"/>
+          <p:cNvPr id="23" name="Shape 20"/>
           <p:cNvSpPr/>
           <p:nvPr/>
         </p:nvSpPr>
@@ -16862,7 +17048,7 @@
       </p:sp>
       <p:sp>
         <p:nvSpPr>
-          <p:cNvPr id="22" name="Text 20"/>
+          <p:cNvPr id="24" name="Text 21"/>
           <p:cNvSpPr txBox="1"/>
           <p:nvPr/>
         </p:nvSpPr>
@@ -16901,7 +17087,7 @@
       </p:sp>
       <p:sp>
         <p:nvSpPr>
-          <p:cNvPr id="23" name="Shape 21"/>
+          <p:cNvPr id="25" name="Shape 22"/>
           <p:cNvSpPr/>
           <p:nvPr/>
         </p:nvSpPr>
@@ -16926,7 +17112,7 @@
       </p:sp>
       <p:sp>
         <p:nvSpPr>
-          <p:cNvPr id="24" name="Text 22"/>
+          <p:cNvPr id="26" name="Text 23"/>
           <p:cNvSpPr txBox="1"/>
           <p:nvPr/>
         </p:nvSpPr>
@@ -16965,7 +17151,7 @@
       </p:sp>
       <p:sp>
         <p:nvSpPr>
-          <p:cNvPr id="25" name="Shape 23"/>
+          <p:cNvPr id="27" name="Shape 24"/>
           <p:cNvSpPr/>
           <p:nvPr/>
         </p:nvSpPr>
@@ -16990,7 +17176,7 @@
       </p:sp>
       <p:sp>
         <p:nvSpPr>
-          <p:cNvPr id="26" name="Shape 24"/>
+          <p:cNvPr id="28" name="Shape 25"/>
           <p:cNvSpPr/>
           <p:nvPr/>
         </p:nvSpPr>
@@ -17015,7 +17201,7 @@
       </p:sp>
       <p:sp>
         <p:nvSpPr>
-          <p:cNvPr id="27" name="Text 25"/>
+          <p:cNvPr id="29" name="Text 26"/>
           <p:cNvSpPr txBox="1"/>
           <p:nvPr/>
         </p:nvSpPr>
@@ -17054,7 +17240,7 @@
       </p:sp>
       <p:sp>
         <p:nvSpPr>
-          <p:cNvPr id="28" name="Shape 26"/>
+          <p:cNvPr id="30" name="Shape 27"/>
           <p:cNvSpPr/>
           <p:nvPr/>
         </p:nvSpPr>
@@ -17079,7 +17265,7 @@
       </p:sp>
       <p:sp>
         <p:nvSpPr>
-          <p:cNvPr id="29" name="Text 27"/>
+          <p:cNvPr id="31" name="Text 28"/>
           <p:cNvSpPr txBox="1"/>
           <p:nvPr/>
         </p:nvSpPr>
@@ -17118,7 +17304,7 @@
       </p:sp>
       <p:sp>
         <p:nvSpPr>
-          <p:cNvPr id="30" name="Shape 28"/>
+          <p:cNvPr id="32" name="Shape 29"/>
           <p:cNvSpPr/>
           <p:nvPr/>
         </p:nvSpPr>
@@ -17143,7 +17329,7 @@
       </p:sp>
       <p:sp>
         <p:nvSpPr>
-          <p:cNvPr id="31" name="Shape 29"/>
+          <p:cNvPr id="33" name="Shape 30"/>
           <p:cNvSpPr/>
           <p:nvPr/>
         </p:nvSpPr>
@@ -17168,7 +17354,7 @@
       </p:sp>
       <p:sp>
         <p:nvSpPr>
-          <p:cNvPr id="32" name="Text 30"/>
+          <p:cNvPr id="34" name="Text 31"/>
           <p:cNvSpPr txBox="1"/>
           <p:nvPr/>
         </p:nvSpPr>
@@ -17207,7 +17393,7 @@
       </p:sp>
       <p:sp>
         <p:nvSpPr>
-          <p:cNvPr id="33" name="Shape 31"/>
+          <p:cNvPr id="35" name="Shape 32"/>
           <p:cNvSpPr/>
           <p:nvPr/>
         </p:nvSpPr>
@@ -17232,7 +17418,7 @@
       </p:sp>
       <p:sp>
         <p:nvSpPr>
-          <p:cNvPr id="34" name="Text 32"/>
+          <p:cNvPr id="36" name="Text 33"/>
           <p:cNvSpPr txBox="1"/>
           <p:nvPr/>
         </p:nvSpPr>
@@ -17271,7 +17457,7 @@
       </p:sp>
       <p:sp>
         <p:nvSpPr>
-          <p:cNvPr id="35" name="Shape 33"/>
+          <p:cNvPr id="37" name="Shape 34"/>
           <p:cNvSpPr/>
           <p:nvPr/>
         </p:nvSpPr>
@@ -17296,7 +17482,7 @@
       </p:sp>
       <p:sp>
         <p:nvSpPr>
-          <p:cNvPr id="36" name="Shape 34"/>
+          <p:cNvPr id="38" name="Shape 35"/>
           <p:cNvSpPr/>
           <p:nvPr/>
         </p:nvSpPr>
@@ -17321,7 +17507,7 @@
       </p:sp>
       <p:sp>
         <p:nvSpPr>
-          <p:cNvPr id="37" name="Text 35"/>
+          <p:cNvPr id="39" name="Text 36"/>
           <p:cNvSpPr txBox="1"/>
           <p:nvPr/>
         </p:nvSpPr>
@@ -17360,7 +17546,7 @@
       </p:sp>
       <p:sp>
         <p:nvSpPr>
-          <p:cNvPr id="38" name="Tarjeta PUNTO DE CONTROL"/>
+          <p:cNvPr id="40" name="Tarjeta PUNTO DE CONTROL"/>
           <p:cNvSpPr/>
           <p:nvPr/>
         </p:nvSpPr>
@@ -17392,7 +17578,7 @@
       </p:sp>
       <p:sp>
         <p:nvSpPr>
-          <p:cNvPr id="39" name="Shape 37"/>
+          <p:cNvPr id="41" name="Shape 38"/>
           <p:cNvSpPr/>
           <p:nvPr/>
         </p:nvSpPr>
@@ -17417,7 +17603,7 @@
       </p:sp>
       <p:sp>
         <p:nvSpPr>
-          <p:cNvPr id="40" name="Text 38"/>
+          <p:cNvPr id="42" name="Text 39"/>
           <p:cNvSpPr txBox="1"/>
           <p:nvPr/>
         </p:nvSpPr>
@@ -17456,7 +17642,7 @@
       </p:sp>
       <p:sp>
         <p:nvSpPr>
-          <p:cNvPr id="41" name="Text 39"/>
+          <p:cNvPr id="43" name="Text 40"/>
           <p:cNvSpPr txBox="1"/>
           <p:nvPr/>
         </p:nvSpPr>
@@ -17495,7 +17681,7 @@
       </p:sp>
       <p:sp>
         <p:nvSpPr>
-          <p:cNvPr id="42" name="Text 40"/>
+          <p:cNvPr id="44" name="Text 41"/>
           <p:cNvSpPr txBox="1"/>
           <p:nvPr/>
         </p:nvSpPr>

</xml_diff>